<commit_message>
feat(mapping): refine power metering, add speed/level sensor classification, and prioritize MCC switchgear
</commit_message>
<xml_diff>
--- a/inteqc_io_finder_final_presentation.pptx
+++ b/inteqc_io_finder_final_presentation.pptx
@@ -3307,7 +3307,7 @@
                 <a:ea typeface="Segoe UI" pitchFamily="34" charset="-122"/>
                 <a:cs typeface="Segoe UI" pitchFamily="34" charset="-120"/>
               </a:rPr>
-              <a:t>• การจัดทำเอกสารส่งมอบงาน (User Manual, Developer Guide) ที่เป็นมืออาชีพ</a:t>
+              <a:t>• การจัดทำเอกสารส่งมอบงาน (User Manual, Developer Guide) </a:t>
             </a:r>
             <a:endParaRPr lang="en-US" sz="1000" dirty="0"/>
           </a:p>
@@ -7322,7 +7322,51 @@
                 <a:ea typeface="Segoe UI" pitchFamily="34" charset="-122"/>
                 <a:cs typeface="Segoe UI" pitchFamily="34" charset="-120"/>
               </a:rPr>
-              <a:t>เชื่อมโยงผังวงจรไฟฟ้าที่สัมพันธ์กับเครื่องจักรได้ถึง 5,076 จุดเชื่อมโยง ครอบคลุมเครื่องจักร 2,432 ตัว โดยผ่านการคัดกรองค่าพิกัดไฟฟ้า (ตัดขยะ 5.5KW, 25A) ทิ้ง 100%</a:t>
+              <a:t>เชื่อมโยงผังวงจรไฟฟ้าที่สัมพันธ์กับเครื่องจักรได้ถึง 5,076 จุดเชื่อมโยง ครอบคลุมเครื่องจักร 2,432 ตัว </a:t>
+            </a:r>
+            <a:r>
+              <a:rPr lang="en-US" sz="1050" dirty="0" err="1">
+                <a:solidFill>
+                  <a:srgbClr val="0F172A"/>
+                </a:solidFill>
+                <a:latin typeface="Segoe UI" pitchFamily="34" charset="0"/>
+                <a:ea typeface="Segoe UI" pitchFamily="34" charset="-122"/>
+                <a:cs typeface="Segoe UI" pitchFamily="34" charset="-120"/>
+              </a:rPr>
+              <a:t>โดยผ่านการคัดกรองค่าพิกัดไฟฟ้า</a:t>
+            </a:r>
+            <a:r>
+              <a:rPr lang="en-US" sz="1050" dirty="0">
+                <a:solidFill>
+                  <a:srgbClr val="0F172A"/>
+                </a:solidFill>
+                <a:latin typeface="Segoe UI" pitchFamily="34" charset="0"/>
+                <a:ea typeface="Segoe UI" pitchFamily="34" charset="-122"/>
+                <a:cs typeface="Segoe UI" pitchFamily="34" charset="-120"/>
+              </a:rPr>
+              <a:t> (</a:t>
+            </a:r>
+            <a:r>
+              <a:rPr lang="th-TH" sz="1050" dirty="0">
+                <a:solidFill>
+                  <a:srgbClr val="0F172A"/>
+                </a:solidFill>
+                <a:latin typeface="Segoe UI" pitchFamily="34" charset="0"/>
+                <a:ea typeface="Segoe UI" pitchFamily="34" charset="-122"/>
+                <a:cs typeface="Segoe UI" pitchFamily="34" charset="-120"/>
+              </a:rPr>
+              <a:t>กรอง</a:t>
+            </a:r>
+            <a:r>
+              <a:rPr lang="en-US" sz="1050" dirty="0">
+                <a:solidFill>
+                  <a:srgbClr val="0F172A"/>
+                </a:solidFill>
+                <a:latin typeface="Segoe UI" pitchFamily="34" charset="0"/>
+                <a:ea typeface="Segoe UI" pitchFamily="34" charset="-122"/>
+                <a:cs typeface="Segoe UI" pitchFamily="34" charset="-120"/>
+              </a:rPr>
+              <a:t> 5.5KW, 25A) ทิ้ง 100%</a:t>
             </a:r>
             <a:endParaRPr lang="en-US" sz="1050" dirty="0"/>
           </a:p>
@@ -7853,7 +7897,7 @@
           <p:nvPr>
             <p:extLst>
               <p:ext uri="{D42A27DB-BD31-4B8C-83A1-F6EECF244321}">
-                <p14:modId xmlns:p14="http://schemas.microsoft.com/office/powerpoint/2010/main" val="1579011935"/>
+                <p14:modId xmlns:p14="http://schemas.microsoft.com/office/powerpoint/2010/main" val="1820185932"/>
               </p:ext>
             </p:extLst>
           </p:nvPr>
@@ -8452,6 +8496,17 @@
                         <a:buNone/>
                       </a:pPr>
                       <a:r>
+                        <a:rPr lang="en-US" sz="950" dirty="0" err="1">
+                          <a:solidFill>
+                            <a:srgbClr val="000000"/>
+                          </a:solidFill>
+                          <a:latin typeface="Segoe UI" pitchFamily="34" charset="0"/>
+                          <a:ea typeface="Segoe UI" pitchFamily="34" charset="-122"/>
+                          <a:cs typeface="Segoe UI" pitchFamily="34" charset="-120"/>
+                        </a:rPr>
+                        <a:t>ระยะเวลาโหลดเพื่อดูวงจร</a:t>
+                      </a:r>
+                      <a:r>
                         <a:rPr lang="en-US" sz="950" dirty="0">
                           <a:solidFill>
                             <a:srgbClr val="000000"/>
@@ -8460,7 +8515,7 @@
                           <a:ea typeface="Segoe UI" pitchFamily="34" charset="-122"/>
                           <a:cs typeface="Segoe UI" pitchFamily="34" charset="-120"/>
                         </a:rPr>
-                        <a:t>ระยะเวลาโหลดเพื่อดูวงจร (TTI)</a:t>
+                        <a:t> </a:t>
                       </a:r>
                       <a:endParaRPr lang="en-US" sz="950" dirty="0">
                         <a:latin typeface="Segoe UI" charset="0"/>

</xml_diff>